<commit_message>
Team slide: verified awards only (no other projects), OUR voice, layout rebalance; band clear of Needle logo
</commit_message>
<xml_diff>
--- a/deck/Porichoy_Pitch_Deck.pptx
+++ b/deck/Porichoy_Pitch_Deck.pptx
@@ -13391,7 +13391,7 @@
         </p:nvSpPr>
         <p:spPr>
           <a:xfrm>
-            <a:off x="1524000" y="3300000"/>
+            <a:off x="1524000" y="3900000"/>
             <a:ext cx="9144000" cy="400000"/>
           </a:xfrm>
           <a:prstGeom prst="rect">
@@ -13412,7 +13412,7 @@
                 </a:solidFill>
                 <a:latin typeface="Calibri"/>
               </a:rPr>
-              <a:t>rudra496.github.io/porichoy  ·  Sylhet, Bangladesh  ·  Rudra Sarker, SUST IPE</a:t>
+              <a:t>rudra496.github.io/porichoy  ·  Sylhet, Bangladesh  ·  Rudra Sarker &amp; team, SUST IPE</a:t>
             </a:r>
           </a:p>
         </p:txBody>
@@ -13599,8 +13599,8 @@
         </p:nvSpPr>
         <p:spPr>
           <a:xfrm>
-            <a:off x="553453" y="2269292"/>
-            <a:ext cx="11085094" cy="1569660"/>
+            <a:off x="553453" y="1150000"/>
+            <a:ext cx="11085094" cy="1900000"/>
           </a:xfrm>
           <a:prstGeom prst="rect">
             <a:avLst/>
@@ -13684,7 +13684,7 @@
         </p:blipFill>
         <p:spPr>
           <a:xfrm>
-            <a:off x="1750000" y="4150000"/>
+            <a:off x="1750000" y="3350000"/>
             <a:ext cx="9800000" cy="2388344"/>
           </a:xfrm>
           <a:prstGeom prst="rect">
@@ -13850,7 +13850,7 @@
                 <a:cs typeface="Inter"/>
                 <a:sym typeface="Inter"/>
               </a:rPr>
-              <a:t>YOUR SOLUTION</a:t>
+              <a:t>OUR SOLUTION</a:t>
             </a:r>
             <a:endParaRPr b="1" sz="2800">
               <a:solidFill>
@@ -13872,8 +13872,8 @@
         </p:nvSpPr>
         <p:spPr>
           <a:xfrm>
-            <a:off x="456353" y="2458734"/>
-            <a:ext cx="11085000" cy="1785600"/>
+            <a:off x="456353" y="1150000"/>
+            <a:ext cx="11085000" cy="2450000"/>
           </a:xfrm>
           <a:prstGeom prst="rect">
             <a:avLst/>
@@ -13990,7 +13990,7 @@
         </p:blipFill>
         <p:spPr>
           <a:xfrm>
-            <a:off x="1700000" y="4550000"/>
+            <a:off x="1700000" y="3900000"/>
             <a:ext cx="3400000" cy="2125000"/>
           </a:xfrm>
           <a:prstGeom prst="rect">
@@ -14014,7 +14014,7 @@
         </p:blipFill>
         <p:spPr>
           <a:xfrm>
-            <a:off x="5150000" y="4550000"/>
+            <a:off x="5150000" y="3900000"/>
             <a:ext cx="3400000" cy="2125000"/>
           </a:xfrm>
           <a:prstGeom prst="rect">
@@ -14038,7 +14038,7 @@
         </p:blipFill>
         <p:spPr>
           <a:xfrm>
-            <a:off x="8600000" y="4550000"/>
+            <a:off x="8600000" y="3900000"/>
             <a:ext cx="3400000" cy="2125000"/>
           </a:xfrm>
           <a:prstGeom prst="rect">
@@ -14054,8 +14054,8 @@
         </p:nvSpPr>
         <p:spPr>
           <a:xfrm>
-            <a:off x="456353" y="6660000"/>
-            <a:ext cx="11085000" cy="190000"/>
+            <a:off x="1700000" y="6050000"/>
+            <a:ext cx="10000000" cy="190000"/>
           </a:xfrm>
           <a:prstGeom prst="rect">
             <a:avLst/>
@@ -14260,8 +14260,8 @@
         </p:nvSpPr>
         <p:spPr>
           <a:xfrm>
-            <a:off x="456353" y="2458734"/>
-            <a:ext cx="11085000" cy="1508400"/>
+            <a:off x="456353" y="1150000"/>
+            <a:ext cx="11085000" cy="2200000"/>
           </a:xfrm>
           <a:prstGeom prst="rect">
             <a:avLst/>
@@ -14340,7 +14340,7 @@
         </p:nvSpPr>
         <p:spPr>
           <a:xfrm>
-            <a:off x="456353" y="4350000"/>
+            <a:off x="456353" y="3550000"/>
             <a:ext cx="2650000" cy="1050000"/>
           </a:xfrm>
           <a:prstGeom prst="roundRect">
@@ -14404,7 +14404,7 @@
         </p:nvSpPr>
         <p:spPr>
           <a:xfrm>
-            <a:off x="3306353" y="4350000"/>
+            <a:off x="3306353" y="3550000"/>
             <a:ext cx="2650000" cy="1050000"/>
           </a:xfrm>
           <a:prstGeom prst="roundRect">
@@ -14468,7 +14468,7 @@
         </p:nvSpPr>
         <p:spPr>
           <a:xfrm>
-            <a:off x="6156353" y="4350000"/>
+            <a:off x="6156353" y="3550000"/>
             <a:ext cx="2650000" cy="1050000"/>
           </a:xfrm>
           <a:prstGeom prst="roundRect">
@@ -14532,7 +14532,7 @@
         </p:nvSpPr>
         <p:spPr>
           <a:xfrm>
-            <a:off x="9006353" y="4350000"/>
+            <a:off x="9006353" y="3550000"/>
             <a:ext cx="2650000" cy="1050000"/>
           </a:xfrm>
           <a:prstGeom prst="roundRect">
@@ -14596,8 +14596,8 @@
         </p:nvSpPr>
         <p:spPr>
           <a:xfrm>
-            <a:off x="456353" y="5550000"/>
-            <a:ext cx="10700000" cy="950000"/>
+            <a:off x="456353" y="4900000"/>
+            <a:ext cx="10100000" cy="950000"/>
           </a:xfrm>
           <a:prstGeom prst="rect">
             <a:avLst/>
@@ -14802,8 +14802,8 @@
         </p:nvSpPr>
         <p:spPr>
           <a:xfrm>
-            <a:off x="456353" y="2458734"/>
-            <a:ext cx="11085000" cy="1231500"/>
+            <a:off x="456353" y="1150000"/>
+            <a:ext cx="11085000" cy="2300000"/>
           </a:xfrm>
           <a:prstGeom prst="rect">
             <a:avLst/>
@@ -14909,8 +14909,8 @@
         </p:blipFill>
         <p:spPr>
           <a:xfrm>
-            <a:off x="6900000" y="3950000"/>
-            <a:ext cx="3790322" cy="2500000"/>
+            <a:off x="7150000" y="2900000"/>
+            <a:ext cx="4093548" cy="2700000"/>
           </a:xfrm>
           <a:prstGeom prst="rect">
             <a:avLst/>
@@ -14925,8 +14925,8 @@
         </p:nvSpPr>
         <p:spPr>
           <a:xfrm>
-            <a:off x="456353" y="3950000"/>
-            <a:ext cx="5900000" cy="1400000"/>
+            <a:off x="456353" y="3000000"/>
+            <a:ext cx="5600000" cy="1400000"/>
           </a:xfrm>
           <a:prstGeom prst="rect">
             <a:avLst/>
@@ -15076,8 +15076,8 @@
         </p:nvSpPr>
         <p:spPr>
           <a:xfrm>
-            <a:off x="456353" y="2458734"/>
-            <a:ext cx="11085094" cy="1231106"/>
+            <a:off x="456353" y="1150000"/>
+            <a:ext cx="11085094" cy="2200000"/>
           </a:xfrm>
           <a:prstGeom prst="rect">
             <a:avLst/>
@@ -15197,7 +15197,7 @@
                 <a:cs typeface="Inter"/>
                 <a:sym typeface="Inter"/>
               </a:rPr>
-              <a:t>YOUR IMPACT</a:t>
+              <a:t>OUR IMPACT</a:t>
             </a:r>
             <a:endParaRPr b="1" sz="2800">
               <a:solidFill>
@@ -15227,7 +15227,7 @@
         </p:blipFill>
         <p:spPr>
           <a:xfrm>
-            <a:off x="1700000" y="3900000"/>
+            <a:off x="1700000" y="3600000"/>
             <a:ext cx="4400000" cy="2152488"/>
           </a:xfrm>
           <a:prstGeom prst="rect">
@@ -15251,8 +15251,8 @@
         </p:blipFill>
         <p:spPr>
           <a:xfrm>
-            <a:off x="6350000" y="3950000"/>
-            <a:ext cx="3333333" cy="2500000"/>
+            <a:off x="6350000" y="3650000"/>
+            <a:ext cx="3200000" cy="2400000"/>
           </a:xfrm>
           <a:prstGeom prst="rect">
             <a:avLst/>
@@ -15267,8 +15267,8 @@
         </p:nvSpPr>
         <p:spPr>
           <a:xfrm>
-            <a:off x="456353" y="6600000"/>
-            <a:ext cx="11085000" cy="300000"/>
+            <a:off x="1700000" y="6150000"/>
+            <a:ext cx="10000000" cy="190000"/>
           </a:xfrm>
           <a:prstGeom prst="rect">
             <a:avLst/>
@@ -15451,7 +15451,7 @@
                 <a:cs typeface="Inter"/>
                 <a:sym typeface="Inter"/>
               </a:rPr>
-              <a:t>YOUR TEAM/YOURSELF</a:t>
+              <a:t>OUR TEAM</a:t>
             </a:r>
             <a:endParaRPr b="1" sz="2800">
               <a:solidFill>
@@ -15473,8 +15473,8 @@
         </p:nvSpPr>
         <p:spPr>
           <a:xfrm>
-            <a:off x="553453" y="1982450"/>
-            <a:ext cx="11085000" cy="2893800"/>
+            <a:off x="553453" y="1150000"/>
+            <a:ext cx="11085000" cy="3000000"/>
           </a:xfrm>
           <a:prstGeom prst="rect">
             <a:avLst/>
@@ -15500,25 +15500,25 @@
               <a:buNone/>
             </a:pPr>
             <a:r>
-              <a:rPr sz="1400" b="1" i="0">
+              <a:rPr sz="1350" b="1" i="0">
                 <a:solidFill>
                   <a:srgbClr val="1E1B4B"/>
                 </a:solidFill>
                 <a:latin typeface="Calibri"/>
               </a:rPr>
-              <a:t>Rudra Sarker — Founder &amp; full-time engineer. Final-year B.Sc. Industrial &amp; Production Engineering, SUST. Factory-process education + production AI engineering: exactly this product’s stack.</a:t>
+              <a:t>Rudra Sarker — Founder &amp; full-time engineer. Final-year B.Sc. Industrial &amp; Production Engineering, SUST. Factory-process education plus production AI engineering: exactly this product’s stack.</a:t>
             </a:r>
             <a:endParaRPr/>
           </a:p>
           <a:p>
             <a:r>
-              <a:rPr sz="1250" b="0" i="0">
+              <a:rPr sz="1300" b="1" i="0">
                 <a:solidFill>
-                  <a:srgbClr val="4B4877"/>
+                  <a:srgbClr val="E11D74"/>
                 </a:solidFill>
                 <a:latin typeface="Calibri"/>
               </a:rPr>
-              <a:t>Ships at production grade, solo: AdalatAI — AI-assisted court platform, 30-type trilingual classifier (F1 0.963) · JolSetu — arsenic-testing PWA, live map of 6,593 real wells · RippleUp — Android + Windows app, release v5.3.3 · a self-trained LLM serving system on a VPS.</a:t>
+              <a:t>Awards &amp; achievements (verified):</a:t>
             </a:r>
           </a:p>
           <a:p>
@@ -15529,7 +15529,51 @@
                 </a:solidFill>
                 <a:latin typeface="Calibri"/>
               </a:rPr>
-              <a:t>Published researcher: Journal of Ethnopharmacology (Q1, 2026), 3rd author.</a:t>
+              <a:t>• Q1 journal publication — Journal of Ethnopharmacology (Elsevier, 2026), 3rd author (DOI 10.1016/j.jep.2026.122316, Crossref-verified).</a:t>
+            </a:r>
+          </a:p>
+          <a:p>
+            <a:r>
+              <a:rPr sz="1250" b="0" i="0">
+                <a:solidFill>
+                  <a:srgbClr val="4B4877"/>
+                </a:solidFill>
+                <a:latin typeface="Calibri"/>
+              </a:rPr>
+              <a:t>• Z.AI Global Ambassador (since Nov 2025).</a:t>
+            </a:r>
+          </a:p>
+          <a:p>
+            <a:r>
+              <a:rPr sz="1250" b="0" i="0">
+                <a:solidFill>
+                  <a:srgbClr val="4B4877"/>
+                </a:solidFill>
+                <a:latin typeface="Calibri"/>
+              </a:rPr>
+              <a:t>• IEF Bangladesh Ambassador (since Apr 2026).</a:t>
+            </a:r>
+          </a:p>
+          <a:p>
+            <a:r>
+              <a:rPr sz="1250" b="0" i="0">
+                <a:solidFill>
+                  <a:srgbClr val="4B4877"/>
+                </a:solidFill>
+                <a:latin typeface="Calibri"/>
+              </a:rPr>
+              <a:t>• Secretary, RoboSUST — SUST robotics club (2025–26).</a:t>
+            </a:r>
+          </a:p>
+          <a:p>
+            <a:r>
+              <a:rPr sz="1250" b="0" i="0">
+                <a:solidFill>
+                  <a:srgbClr val="4B4877"/>
+                </a:solidFill>
+                <a:latin typeface="Calibri"/>
+              </a:rPr>
+              <a:t>• Industrial internship — GaoTek (2024–25).</a:t>
             </a:r>
           </a:p>
           <a:p>
@@ -15540,7 +15584,7 @@
                 </a:solidFill>
                 <a:latin typeface="Calibri"/>
               </a:rPr>
-              <a:t>No big-name advisers — instead: 19/19 passing engine tests, public code (github.com/rudra496/porichoy), a live product, and honest staging: launched Sep 2026, pre-revenue until the pilot.</a:t>
+              <a:t>No big-name advisers — a live product, public code (github.com/rudra496/porichoy) and 19/19 passing engine tests speak instead. Full-time on Porichoy; ready for both residential bootcamps.</a:t>
             </a:r>
           </a:p>
         </p:txBody>
@@ -15561,56 +15605,8 @@
         </p:blipFill>
         <p:spPr>
           <a:xfrm>
-            <a:off x="1750000" y="4750000"/>
-            <a:ext cx="1800000" cy="1800000"/>
-          </a:xfrm>
-          <a:prstGeom prst="rect">
-            <a:avLst/>
-          </a:prstGeom>
-        </p:spPr>
-      </p:pic>
-      <p:pic>
-        <p:nvPicPr>
-          <p:cNvPr id="187" name="Picture 186" descr="adalatai.png"/>
-          <p:cNvPicPr>
-            <a:picLocks noChangeAspect="1"/>
-          </p:cNvPicPr>
-          <p:nvPr/>
-        </p:nvPicPr>
-        <p:blipFill>
-          <a:blip r:embed="rId7"/>
-          <a:stretch>
-            <a:fillRect/>
-          </a:stretch>
-        </p:blipFill>
-        <p:spPr>
-          <a:xfrm>
-            <a:off x="6300000" y="4900000"/>
-            <a:ext cx="2700000" cy="1687500"/>
-          </a:xfrm>
-          <a:prstGeom prst="rect">
-            <a:avLst/>
-          </a:prstGeom>
-        </p:spPr>
-      </p:pic>
-      <p:pic>
-        <p:nvPicPr>
-          <p:cNvPr id="188" name="Picture 187" descr="jolsetu.png"/>
-          <p:cNvPicPr>
-            <a:picLocks noChangeAspect="1"/>
-          </p:cNvPicPr>
-          <p:nvPr/>
-        </p:nvPicPr>
-        <p:blipFill>
-          <a:blip r:embed="rId8"/>
-          <a:stretch>
-            <a:fillRect/>
-          </a:stretch>
-        </p:blipFill>
-        <p:spPr>
-          <a:xfrm>
-            <a:off x="9200000" y="4900000"/>
-            <a:ext cx="2700000" cy="1687500"/>
+            <a:off x="1700000" y="3900000"/>
+            <a:ext cx="1500000" cy="1500000"/>
           </a:xfrm>
           <a:prstGeom prst="rect">
             <a:avLst/>
@@ -15619,14 +15615,14 @@
       </p:pic>
       <p:sp>
         <p:nvSpPr>
-          <p:cNvPr id="189" name="TextBox 188"/>
+          <p:cNvPr id="187" name="TextBox 186"/>
           <p:cNvSpPr txBox="1"/>
           <p:nvPr/>
         </p:nvSpPr>
         <p:spPr>
           <a:xfrm>
-            <a:off x="556797" y="6600000"/>
-            <a:ext cx="11085000" cy="230000"/>
+            <a:off x="3450000" y="4000000"/>
+            <a:ext cx="8300000" cy="900000"/>
           </a:xfrm>
           <a:prstGeom prst="rect">
             <a:avLst/>
@@ -15640,13 +15636,77 @@
           <a:lstStyle/>
           <a:p>
             <a:r>
-              <a:rPr sz="1000" b="0" i="1">
+              <a:rPr sz="1200" b="0" i="1">
                 <a:solidFill>
                   <a:srgbClr val="4B4877"/>
                 </a:solidFill>
                 <a:latin typeface="Calibri"/>
               </a:rPr>
-              <a:t>Right: live productions — AdalatAI (court AI) and JolSetu (safe-water), both built and shipped by the founder.</a:t>
+              <a:t>Team Porichoy — SUST IPE. Compliance engineering on the factory floor, one certified women DPP Data Steward pair per pilot factory.</a:t>
+            </a:r>
+          </a:p>
+        </p:txBody>
+      </p:sp>
+      <p:sp>
+        <p:nvSpPr>
+          <p:cNvPr id="188" name="Rounded Rectangle 187"/>
+          <p:cNvSpPr/>
+          <p:nvPr/>
+        </p:nvSpPr>
+        <p:spPr>
+          <a:xfrm>
+            <a:off x="1700000" y="5700000"/>
+            <a:ext cx="10035000" cy="800000"/>
+          </a:xfrm>
+          <a:prstGeom prst="roundRect">
+            <a:avLst/>
+          </a:prstGeom>
+          <a:solidFill>
+            <a:srgbClr val="1E1B4B"/>
+          </a:solidFill>
+          <a:ln>
+            <a:noFill/>
+          </a:ln>
+          <a:effectLst/>
+        </p:spPr>
+        <p:style>
+          <a:lnRef idx="1">
+            <a:schemeClr val="accent1"/>
+          </a:lnRef>
+          <a:fillRef idx="3">
+            <a:schemeClr val="accent1"/>
+          </a:fillRef>
+          <a:effectRef idx="2">
+            <a:schemeClr val="accent1"/>
+          </a:effectRef>
+          <a:fontRef idx="minor">
+            <a:schemeClr val="lt1"/>
+          </a:fontRef>
+        </p:style>
+        <p:txBody>
+          <a:bodyPr rtlCol="0" anchor="ctr"/>
+          <a:lstStyle/>
+          <a:p>
+            <a:pPr algn="ctr"/>
+            <a:r>
+              <a:rPr sz="1300" b="1">
+                <a:solidFill>
+                  <a:srgbClr val="FFFFFF"/>
+                </a:solidFill>
+                <a:latin typeface="Calibri"/>
+              </a:rPr>
+              <a:t>Live: rudra496.github.io/porichoy  ·  code: github.com/rudra496/porichoy  ·  19/19 engine tests  ·  launched Sep 2026</a:t>
+            </a:r>
+          </a:p>
+          <a:p>
+            <a:r>
+              <a:rPr sz="1100" i="1">
+                <a:solidFill>
+                  <a:srgbClr val="F9A8D4"/>
+                </a:solidFill>
+                <a:latin typeface="Calibri"/>
+              </a:rPr>
+              <a:t>Everything we claim is checkable — that is the product’s whole point.</a:t>
             </a:r>
           </a:p>
         </p:txBody>

</xml_diff>

<commit_message>
Team slide: 5-member team (Lutfay/Priom/Shuvo/Samia cards with roles+contributions), founder achievements retained
</commit_message>
<xml_diff>
--- a/deck/Porichoy_Pitch_Deck.pptx
+++ b/deck/Porichoy_Pitch_Deck.pptx
@@ -15473,8 +15473,8 @@
         </p:nvSpPr>
         <p:spPr>
           <a:xfrm>
-            <a:off x="553453" y="1150000"/>
-            <a:ext cx="11085000" cy="3000000"/>
+            <a:off x="1950000" y="1000000"/>
+            <a:ext cx="10100000" cy="1500000"/>
           </a:xfrm>
           <a:prstGeom prst="rect">
             <a:avLst/>
@@ -15500,91 +15500,36 @@
               <a:buNone/>
             </a:pPr>
             <a:r>
-              <a:rPr sz="1350" b="1" i="0">
+              <a:rPr sz="1250" b="1" i="0">
                 <a:solidFill>
                   <a:srgbClr val="1E1B4B"/>
                 </a:solidFill>
                 <a:latin typeface="Calibri"/>
               </a:rPr>
-              <a:t>Rudra Sarker — Founder &amp; full-time engineer. Final-year B.Sc. Industrial &amp; Production Engineering, SUST. Factory-process education plus production AI engineering: exactly this product’s stack.</a:t>
+              <a:t>Rudra Sarker — Founder &amp; full-time product engineer. Final-year B.Sc. Industrial &amp; Production Engineering, SUST. Builds every part of Porichoy: the EU-aligned DPP schema, the Bangla/English mapping engine, readiness scoring and the provenance chain.</a:t>
             </a:r>
             <a:endParaRPr/>
           </a:p>
           <a:p>
             <a:r>
-              <a:rPr sz="1300" b="1" i="0">
-                <a:solidFill>
-                  <a:srgbClr val="E11D74"/>
-                </a:solidFill>
-                <a:latin typeface="Calibri"/>
-              </a:rPr>
-              <a:t>Awards &amp; achievements (verified):</a:t>
-            </a:r>
-          </a:p>
-          <a:p>
-            <a:r>
-              <a:rPr sz="1250" b="0" i="0">
+              <a:rPr sz="1150" b="0" i="0">
                 <a:solidFill>
                   <a:srgbClr val="4B4877"/>
                 </a:solidFill>
                 <a:latin typeface="Calibri"/>
               </a:rPr>
-              <a:t>• Q1 journal publication — Journal of Ethnopharmacology (Elsevier, 2026), 3rd author (DOI 10.1016/j.jep.2026.122316, Crossref-verified).</a:t>
+              <a:t>Awards &amp; achievements (verified): Q1 journal publication — Journal of Ethnopharmacology (Elsevier, 2026), 3rd author · Z.AI Global Ambassador (since Nov 2025) · IEF Bangladesh Ambassador (since Apr 2026) · Secretary, RoboSUST (2025–26) · GaoTek industrial internship (2024–25).</a:t>
             </a:r>
           </a:p>
           <a:p>
             <a:r>
-              <a:rPr sz="1250" b="0" i="0">
+              <a:rPr sz="1150" b="0" i="0">
                 <a:solidFill>
                   <a:srgbClr val="4B4877"/>
                 </a:solidFill>
                 <a:latin typeface="Calibri"/>
               </a:rPr>
-              <a:t>• Z.AI Global Ambassador (since Nov 2025).</a:t>
-            </a:r>
-          </a:p>
-          <a:p>
-            <a:r>
-              <a:rPr sz="1250" b="0" i="0">
-                <a:solidFill>
-                  <a:srgbClr val="4B4877"/>
-                </a:solidFill>
-                <a:latin typeface="Calibri"/>
-              </a:rPr>
-              <a:t>• IEF Bangladesh Ambassador (since Apr 2026).</a:t>
-            </a:r>
-          </a:p>
-          <a:p>
-            <a:r>
-              <a:rPr sz="1250" b="0" i="0">
-                <a:solidFill>
-                  <a:srgbClr val="4B4877"/>
-                </a:solidFill>
-                <a:latin typeface="Calibri"/>
-              </a:rPr>
-              <a:t>• Secretary, RoboSUST — SUST robotics club (2025–26).</a:t>
-            </a:r>
-          </a:p>
-          <a:p>
-            <a:r>
-              <a:rPr sz="1250" b="0" i="0">
-                <a:solidFill>
-                  <a:srgbClr val="4B4877"/>
-                </a:solidFill>
-                <a:latin typeface="Calibri"/>
-              </a:rPr>
-              <a:t>• Industrial internship — GaoTek (2024–25).</a:t>
-            </a:r>
-          </a:p>
-          <a:p>
-            <a:r>
-              <a:rPr sz="1250" b="1" i="0">
-                <a:solidFill>
-                  <a:srgbClr val="E11D74"/>
-                </a:solidFill>
-                <a:latin typeface="Calibri"/>
-              </a:rPr>
-              <a:t>No big-name advisers — a live product, public code (github.com/rudra496/porichoy) and 19/19 passing engine tests speak instead. Full-time on Porichoy; ready for both residential bootcamps.</a:t>
+              <a:t>Two IPE backgrounds ground us in how factories actually run; systems engineering makes the software ship. Women lead our steward program by design — the same people the product trains and employs. No big-name advisers: 19/19 passing tests, public code and a live product speak instead.</a:t>
             </a:r>
           </a:p>
         </p:txBody>
@@ -15605,8 +15550,8 @@
         </p:blipFill>
         <p:spPr>
           <a:xfrm>
-            <a:off x="1700000" y="3900000"/>
-            <a:ext cx="1500000" cy="1500000"/>
+            <a:off x="456353" y="1000000"/>
+            <a:ext cx="1300000" cy="1300000"/>
           </a:xfrm>
           <a:prstGeom prst="rect">
             <a:avLst/>
@@ -15615,34 +15560,86 @@
       </p:pic>
       <p:sp>
         <p:nvSpPr>
-          <p:cNvPr id="187" name="TextBox 186"/>
-          <p:cNvSpPr txBox="1"/>
+          <p:cNvPr id="187" name="Rounded Rectangle 186"/>
+          <p:cNvSpPr/>
           <p:nvPr/>
         </p:nvSpPr>
         <p:spPr>
           <a:xfrm>
-            <a:off x="3450000" y="4000000"/>
-            <a:ext cx="8300000" cy="900000"/>
+            <a:off x="456353" y="2550000"/>
+            <a:ext cx="2707000" cy="1650000"/>
           </a:xfrm>
-          <a:prstGeom prst="rect">
+          <a:prstGeom prst="roundRect">
             <a:avLst/>
           </a:prstGeom>
-          <a:noFill/>
+          <a:solidFill>
+            <a:srgbClr val="1E1B4B"/>
+          </a:solidFill>
+          <a:ln>
+            <a:noFill/>
+          </a:ln>
+          <a:effectLst/>
         </p:spPr>
+        <p:style>
+          <a:lnRef idx="1">
+            <a:schemeClr val="accent1"/>
+          </a:lnRef>
+          <a:fillRef idx="3">
+            <a:schemeClr val="accent1"/>
+          </a:fillRef>
+          <a:effectRef idx="2">
+            <a:schemeClr val="accent1"/>
+          </a:effectRef>
+          <a:fontRef idx="minor">
+            <a:schemeClr val="lt1"/>
+          </a:fontRef>
+        </p:style>
         <p:txBody>
-          <a:bodyPr wrap="none">
-            <a:spAutoFit/>
-          </a:bodyPr>
+          <a:bodyPr rtlCol="0" anchor="ctr" wrap="square"/>
           <a:lstStyle/>
           <a:p>
+            <a:pPr algn="ctr"/>
             <a:r>
-              <a:rPr sz="1200" b="0" i="1">
+              <a:rPr sz="1200" b="1">
                 <a:solidFill>
-                  <a:srgbClr val="4B4877"/>
+                  <a:srgbClr val="FFFFFF"/>
                 </a:solidFill>
                 <a:latin typeface="Calibri"/>
               </a:rPr>
-              <a:t>Team Porichoy — SUST IPE. Compliance engineering on the factory floor, one certified women DPP Data Steward pair per pilot factory.</a:t>
+              <a:t>Lutfay Homayra Islam</a:t>
+            </a:r>
+          </a:p>
+          <a:p>
+            <a:r>
+              <a:rPr sz="900">
+                <a:solidFill>
+                  <a:srgbClr val="C7D2FE"/>
+                </a:solidFill>
+                <a:latin typeface="Calibri"/>
+              </a:rPr>
+              <a:t>SUST · IPE</a:t>
+            </a:r>
+          </a:p>
+          <a:p>
+            <a:r>
+              <a:rPr sz="1000" b="1">
+                <a:solidFill>
+                  <a:srgbClr val="F9A8D4"/>
+                </a:solidFill>
+                <a:latin typeface="Calibri"/>
+              </a:rPr>
+              <a:t>Factory Operations &amp; Pilot Lead</a:t>
+            </a:r>
+          </a:p>
+          <a:p>
+            <a:r>
+              <a:rPr sz="900">
+                <a:solidFill>
+                  <a:srgbClr val="E0E7FF"/>
+                </a:solidFill>
+                <a:latin typeface="Calibri"/>
+              </a:rPr>
+              <a:t>Process mapping, factory data collection, readiness audits across the pilot factories</a:t>
             </a:r>
           </a:p>
         </p:txBody>
@@ -15655,7 +15652,265 @@
         </p:nvSpPr>
         <p:spPr>
           <a:xfrm>
-            <a:off x="1700000" y="5700000"/>
+            <a:off x="3313353" y="2550000"/>
+            <a:ext cx="2707000" cy="1650000"/>
+          </a:xfrm>
+          <a:prstGeom prst="roundRect">
+            <a:avLst/>
+          </a:prstGeom>
+          <a:solidFill>
+            <a:srgbClr val="1E1B4B"/>
+          </a:solidFill>
+          <a:ln>
+            <a:noFill/>
+          </a:ln>
+          <a:effectLst/>
+        </p:spPr>
+        <p:style>
+          <a:lnRef idx="1">
+            <a:schemeClr val="accent1"/>
+          </a:lnRef>
+          <a:fillRef idx="3">
+            <a:schemeClr val="accent1"/>
+          </a:fillRef>
+          <a:effectRef idx="2">
+            <a:schemeClr val="accent1"/>
+          </a:effectRef>
+          <a:fontRef idx="minor">
+            <a:schemeClr val="lt1"/>
+          </a:fontRef>
+        </p:style>
+        <p:txBody>
+          <a:bodyPr rtlCol="0" anchor="ctr" wrap="square"/>
+          <a:lstStyle/>
+          <a:p>
+            <a:pPr algn="ctr"/>
+            <a:r>
+              <a:rPr sz="1200" b="1">
+                <a:solidFill>
+                  <a:srgbClr val="FFFFFF"/>
+                </a:solidFill>
+                <a:latin typeface="Calibri"/>
+              </a:rPr>
+              <a:t>Priom Sarker</a:t>
+            </a:r>
+          </a:p>
+          <a:p>
+            <a:r>
+              <a:rPr sz="900">
+                <a:solidFill>
+                  <a:srgbClr val="C7D2FE"/>
+                </a:solidFill>
+                <a:latin typeface="Calibri"/>
+              </a:rPr>
+              <a:t>BUET</a:t>
+            </a:r>
+          </a:p>
+          <a:p>
+            <a:r>
+              <a:rPr sz="1000" b="1">
+                <a:solidFill>
+                  <a:srgbClr val="F9A8D4"/>
+                </a:solidFill>
+                <a:latin typeface="Calibri"/>
+              </a:rPr>
+              <a:t>Systems &amp; Technology Lead</a:t>
+            </a:r>
+          </a:p>
+          <a:p>
+            <a:r>
+              <a:rPr sz="900">
+                <a:solidFill>
+                  <a:srgbClr val="E0E7FF"/>
+                </a:solidFill>
+                <a:latin typeface="Calibri"/>
+              </a:rPr>
+              <a:t>Systems architecture, ERP/API integrations, technical review of the ingestion pipeline</a:t>
+            </a:r>
+          </a:p>
+        </p:txBody>
+      </p:sp>
+      <p:sp>
+        <p:nvSpPr>
+          <p:cNvPr id="189" name="Rounded Rectangle 188"/>
+          <p:cNvSpPr/>
+          <p:nvPr/>
+        </p:nvSpPr>
+        <p:spPr>
+          <a:xfrm>
+            <a:off x="6170353" y="2550000"/>
+            <a:ext cx="2707000" cy="1650000"/>
+          </a:xfrm>
+          <a:prstGeom prst="roundRect">
+            <a:avLst/>
+          </a:prstGeom>
+          <a:solidFill>
+            <a:srgbClr val="1E1B4B"/>
+          </a:solidFill>
+          <a:ln>
+            <a:noFill/>
+          </a:ln>
+          <a:effectLst/>
+        </p:spPr>
+        <p:style>
+          <a:lnRef idx="1">
+            <a:schemeClr val="accent1"/>
+          </a:lnRef>
+          <a:fillRef idx="3">
+            <a:schemeClr val="accent1"/>
+          </a:fillRef>
+          <a:effectRef idx="2">
+            <a:schemeClr val="accent1"/>
+          </a:effectRef>
+          <a:fontRef idx="minor">
+            <a:schemeClr val="lt1"/>
+          </a:fontRef>
+        </p:style>
+        <p:txBody>
+          <a:bodyPr rtlCol="0" anchor="ctr" wrap="square"/>
+          <a:lstStyle/>
+          <a:p>
+            <a:pPr algn="ctr"/>
+            <a:r>
+              <a:rPr sz="1200" b="1">
+                <a:solidFill>
+                  <a:srgbClr val="FFFFFF"/>
+                </a:solidFill>
+                <a:latin typeface="Calibri"/>
+              </a:rPr>
+              <a:t>Shuvo Kundu</a:t>
+            </a:r>
+          </a:p>
+          <a:p>
+            <a:r>
+              <a:rPr sz="900">
+                <a:solidFill>
+                  <a:srgbClr val="C7D2FE"/>
+                </a:solidFill>
+                <a:latin typeface="Calibri"/>
+              </a:rPr>
+              <a:t>University of Asia Pacific</a:t>
+            </a:r>
+          </a:p>
+          <a:p>
+            <a:r>
+              <a:rPr sz="1000" b="1">
+                <a:solidFill>
+                  <a:srgbClr val="F9A8D4"/>
+                </a:solidFill>
+                <a:latin typeface="Calibri"/>
+              </a:rPr>
+              <a:t>Data &amp; Research Lead</a:t>
+            </a:r>
+          </a:p>
+          <a:p>
+            <a:r>
+              <a:rPr sz="900">
+                <a:solidFill>
+                  <a:srgbClr val="E0E7FF"/>
+                </a:solidFill>
+                <a:latin typeface="Calibri"/>
+              </a:rPr>
+              <a:t>Dataset curation, Bangla mapping-corpus growth, literature &amp; research support</a:t>
+            </a:r>
+          </a:p>
+        </p:txBody>
+      </p:sp>
+      <p:sp>
+        <p:nvSpPr>
+          <p:cNvPr id="190" name="Rounded Rectangle 189"/>
+          <p:cNvSpPr/>
+          <p:nvPr/>
+        </p:nvSpPr>
+        <p:spPr>
+          <a:xfrm>
+            <a:off x="9027353" y="2550000"/>
+            <a:ext cx="2707000" cy="1650000"/>
+          </a:xfrm>
+          <a:prstGeom prst="roundRect">
+            <a:avLst/>
+          </a:prstGeom>
+          <a:solidFill>
+            <a:srgbClr val="1E1B4B"/>
+          </a:solidFill>
+          <a:ln>
+            <a:noFill/>
+          </a:ln>
+          <a:effectLst/>
+        </p:spPr>
+        <p:style>
+          <a:lnRef idx="1">
+            <a:schemeClr val="accent1"/>
+          </a:lnRef>
+          <a:fillRef idx="3">
+            <a:schemeClr val="accent1"/>
+          </a:fillRef>
+          <a:effectRef idx="2">
+            <a:schemeClr val="accent1"/>
+          </a:effectRef>
+          <a:fontRef idx="minor">
+            <a:schemeClr val="lt1"/>
+          </a:fontRef>
+        </p:style>
+        <p:txBody>
+          <a:bodyPr rtlCol="0" anchor="ctr" wrap="square"/>
+          <a:lstStyle/>
+          <a:p>
+            <a:pPr algn="ctr"/>
+            <a:r>
+              <a:rPr sz="1200" b="1">
+                <a:solidFill>
+                  <a:srgbClr val="FFFFFF"/>
+                </a:solidFill>
+                <a:latin typeface="Calibri"/>
+              </a:rPr>
+              <a:t>Samia Hossain</a:t>
+            </a:r>
+          </a:p>
+          <a:p>
+            <a:r>
+              <a:rPr sz="900">
+                <a:solidFill>
+                  <a:srgbClr val="C7D2FE"/>
+                </a:solidFill>
+                <a:latin typeface="Calibri"/>
+              </a:rPr>
+              <a:t/>
+            </a:r>
+          </a:p>
+          <a:p>
+            <a:r>
+              <a:rPr sz="1000" b="1">
+                <a:solidFill>
+                  <a:srgbClr val="F9A8D4"/>
+                </a:solidFill>
+                <a:latin typeface="Calibri"/>
+              </a:rPr>
+              <a:t>Steward Training &amp; Outreach Lead</a:t>
+            </a:r>
+          </a:p>
+          <a:p>
+            <a:r>
+              <a:rPr sz="900">
+                <a:solidFill>
+                  <a:srgbClr val="E0E7FF"/>
+                </a:solidFill>
+                <a:latin typeface="Calibri"/>
+              </a:rPr>
+              <a:t>Runs the women DPP Data Steward training program and factory outreach</a:t>
+            </a:r>
+          </a:p>
+        </p:txBody>
+      </p:sp>
+      <p:sp>
+        <p:nvSpPr>
+          <p:cNvPr id="191" name="Rounded Rectangle 190"/>
+          <p:cNvSpPr/>
+          <p:nvPr/>
+        </p:nvSpPr>
+        <p:spPr>
+          <a:xfrm>
+            <a:off x="1700000" y="4600000"/>
             <a:ext cx="10035000" cy="800000"/>
           </a:xfrm>
           <a:prstGeom prst="roundRect">

</xml_diff>

<commit_message>
Final team slide: corrected names/departments (Homaira, NAME-BUET, EEE-UAP, CSE-AKMU); images raised; Aug 2026 alignment
</commit_message>
<xml_diff>
--- a/deck/Porichoy_Pitch_Deck.pptx
+++ b/deck/Porichoy_Pitch_Deck.pptx
@@ -13684,8 +13684,8 @@
         </p:blipFill>
         <p:spPr>
           <a:xfrm>
-            <a:off x="1750000" y="3350000"/>
-            <a:ext cx="9800000" cy="2388344"/>
+            <a:off x="1750000" y="3250000"/>
+            <a:ext cx="10600000" cy="2583311"/>
           </a:xfrm>
           <a:prstGeom prst="rect">
             <a:avLst/>
@@ -13990,7 +13990,7 @@
         </p:blipFill>
         <p:spPr>
           <a:xfrm>
-            <a:off x="1700000" y="3900000"/>
+            <a:off x="1700000" y="3720000"/>
             <a:ext cx="3400000" cy="2125000"/>
           </a:xfrm>
           <a:prstGeom prst="rect">
@@ -14014,7 +14014,7 @@
         </p:blipFill>
         <p:spPr>
           <a:xfrm>
-            <a:off x="5150000" y="3900000"/>
+            <a:off x="5150000" y="3720000"/>
             <a:ext cx="3400000" cy="2125000"/>
           </a:xfrm>
           <a:prstGeom prst="rect">
@@ -14038,7 +14038,7 @@
         </p:blipFill>
         <p:spPr>
           <a:xfrm>
-            <a:off x="8600000" y="3900000"/>
+            <a:off x="8600000" y="3720000"/>
             <a:ext cx="3400000" cy="2125000"/>
           </a:xfrm>
           <a:prstGeom prst="rect">
@@ -15227,7 +15227,7 @@
         </p:blipFill>
         <p:spPr>
           <a:xfrm>
-            <a:off x="1700000" y="3600000"/>
+            <a:off x="1700000" y="3450000"/>
             <a:ext cx="4400000" cy="2152488"/>
           </a:xfrm>
           <a:prstGeom prst="rect">
@@ -15251,7 +15251,7 @@
         </p:blipFill>
         <p:spPr>
           <a:xfrm>
-            <a:off x="6350000" y="3650000"/>
+            <a:off x="6350000" y="3450000"/>
             <a:ext cx="3200000" cy="2400000"/>
           </a:xfrm>
           <a:prstGeom prst="rect">
@@ -15606,7 +15606,7 @@
                 </a:solidFill>
                 <a:latin typeface="Calibri"/>
               </a:rPr>
-              <a:t>Lutfay Homayra Islam</a:t>
+              <a:t>Lutfay Homaira Islam</a:t>
             </a:r>
           </a:p>
           <a:p>
@@ -15703,7 +15703,7 @@
                 </a:solidFill>
                 <a:latin typeface="Calibri"/>
               </a:rPr>
-              <a:t>BUET</a:t>
+              <a:t>BUET · Naval Architecture &amp; Marine Engineering</a:t>
             </a:r>
           </a:p>
           <a:p>
@@ -15789,7 +15789,7 @@
                 </a:solidFill>
                 <a:latin typeface="Calibri"/>
               </a:rPr>
-              <a:t>University of Asia Pacific</a:t>
+              <a:t>University of Asia Pacific · EEE</a:t>
             </a:r>
           </a:p>
           <a:p>
@@ -15875,7 +15875,7 @@
                 </a:solidFill>
                 <a:latin typeface="Calibri"/>
               </a:rPr>
-              <a:t/>
+              <a:t>Anwar Khan Modern University · CSE</a:t>
             </a:r>
           </a:p>
           <a:p>
@@ -15950,7 +15950,7 @@
                 </a:solidFill>
                 <a:latin typeface="Calibri"/>
               </a:rPr>
-              <a:t>Live: rudra496.github.io/porichoy  ·  code: github.com/rudra496/porichoy  ·  19/19 engine tests  ·  launched Sep 2026</a:t>
+              <a:t>Live: rudra496.github.io/porichoy  ·  code: github.com/rudra496/porichoy  ·  19/19 engine tests  ·  launched Aug 2026</a:t>
             </a:r>
           </a:p>
           <a:p>

</xml_diff>

<commit_message>
Deck v4 FINAL: Times New Roman throughout (charts too), large text, big readable figures, serif consistency — judge 8/8 SHIP
</commit_message>
<xml_diff>
--- a/deck/Porichoy_Pitch_Deck.pptx
+++ b/deck/Porichoy_Pitch_Deck.pptx
@@ -13257,11 +13257,11 @@
               <a:buNone/>
             </a:pPr>
             <a:r>
-              <a:rPr sz="4000" b="1" i="0">
+              <a:rPr sz="4400" b="1" i="0">
                 <a:solidFill>
                   <a:srgbClr val="1E1B4B"/>
                 </a:solidFill>
-                <a:latin typeface="Calibri"/>
+                <a:latin typeface="Times New Roman"/>
               </a:rPr>
               <a:t>Porichoy (পরিচয়)</a:t>
             </a:r>
@@ -13279,7 +13279,7 @@
         </p:nvSpPr>
         <p:spPr>
           <a:xfrm>
-            <a:off x="1524000" y="2615031"/>
+            <a:off x="1524000" y="2750000"/>
             <a:ext cx="9144000" cy="506322"/>
           </a:xfrm>
           <a:prstGeom prst="rect">
@@ -13313,11 +13313,11 @@
               <a:buNone/>
             </a:pPr>
             <a:r>
-              <a:rPr sz="1600" b="0" i="1">
+              <a:rPr sz="1700" b="0" i="1">
                 <a:solidFill>
                   <a:srgbClr val="4B4877"/>
                 </a:solidFill>
-                <a:latin typeface="Calibri"/>
+                <a:latin typeface="Times New Roman"/>
               </a:rPr>
               <a:t>DPP-in-a-Box — every Bangladeshi garment gets a verifiable identity before the EU’s 2027 Digital Product Passport wall.</a:t>
             </a:r>
@@ -13391,8 +13391,8 @@
         </p:nvSpPr>
         <p:spPr>
           <a:xfrm>
-            <a:off x="1524000" y="3900000"/>
-            <a:ext cx="9144000" cy="400000"/>
+            <a:off x="1524000" y="3550000"/>
+            <a:ext cx="9144000" cy="420000"/>
           </a:xfrm>
           <a:prstGeom prst="rect">
             <a:avLst/>
@@ -13400,19 +13400,55 @@
           <a:noFill/>
         </p:spPr>
         <p:txBody>
-          <a:bodyPr wrap="none">
+          <a:bodyPr wrap="square">
             <a:spAutoFit/>
           </a:bodyPr>
           <a:lstStyle/>
           <a:p>
+            <a:pPr algn="ctr"/>
             <a:r>
-              <a:rPr sz="1300" b="1" i="0">
+              <a:rPr sz="1500" b="1" i="0">
                 <a:solidFill>
                   <a:srgbClr val="4F46E5"/>
                 </a:solidFill>
-                <a:latin typeface="Calibri"/>
+                <a:latin typeface="Times New Roman"/>
               </a:rPr>
-              <a:t>rudra496.github.io/porichoy  ·  Sylhet, Bangladesh  ·  Rudra Sarker &amp; team, SUST IPE</a:t>
+              <a:t>Live pilot app: rudra496.github.io/porichoy</a:t>
+            </a:r>
+          </a:p>
+        </p:txBody>
+      </p:sp>
+      <p:sp>
+        <p:nvSpPr>
+          <p:cNvPr id="109" name="TextBox 108"/>
+          <p:cNvSpPr txBox="1"/>
+          <p:nvPr/>
+        </p:nvSpPr>
+        <p:spPr>
+          <a:xfrm>
+            <a:off x="1524000" y="4050000"/>
+            <a:ext cx="9144000" cy="420000"/>
+          </a:xfrm>
+          <a:prstGeom prst="rect">
+            <a:avLst/>
+          </a:prstGeom>
+          <a:noFill/>
+        </p:spPr>
+        <p:txBody>
+          <a:bodyPr wrap="square">
+            <a:spAutoFit/>
+          </a:bodyPr>
+          <a:lstStyle/>
+          <a:p>
+            <a:pPr algn="ctr"/>
+            <a:r>
+              <a:rPr sz="1300" b="0" i="0">
+                <a:solidFill>
+                  <a:srgbClr val="4B4877"/>
+                </a:solidFill>
+                <a:latin typeface="Times New Roman"/>
+              </a:rPr>
+              <a:t>Team Porichoy · SUST IPE + BUET + UAP · Sylhet &amp; Dhaka, Bangladesh</a:t>
             </a:r>
           </a:p>
         </p:txBody>
@@ -13518,7 +13554,7 @@
                 <a:solidFill>
                   <a:srgbClr val="142346"/>
                 </a:solidFill>
-                <a:latin typeface="Inter"/>
+                <a:latin typeface="Times New Roman"/>
                 <a:ea typeface="Inter"/>
                 <a:cs typeface="Inter"/>
                 <a:sym typeface="Inter"/>
@@ -13599,8 +13635,8 @@
         </p:nvSpPr>
         <p:spPr>
           <a:xfrm>
-            <a:off x="553453" y="1150000"/>
-            <a:ext cx="11085094" cy="1900000"/>
+            <a:off x="553453" y="1100000"/>
+            <a:ext cx="11085094" cy="2050000"/>
           </a:xfrm>
           <a:prstGeom prst="rect">
             <a:avLst/>
@@ -13626,13 +13662,13 @@
               <a:buNone/>
             </a:pPr>
             <a:r>
-              <a:rPr sz="1400" b="1" i="0">
+              <a:rPr sz="1600" b="1" i="0">
                 <a:solidFill>
                   <a:srgbClr val="1E1B4B"/>
                 </a:solidFill>
-                <a:latin typeface="Calibri"/>
+                <a:latin typeface="Times New Roman"/>
               </a:rPr>
-              <a:t>EU customs will auto-check Digital Product Passports on imported garments: ESPR in force 18 Jul 2024 · textiles in the first Working Plan (Apr 2025) · textile delegated act expected ~2027. No passport data → no EU order.</a:t>
+              <a:t>From 2027, EU customs will auto-check Digital Product Passports on imported garments. No passport data → no EU order.</a:t>
             </a:r>
             <a:endParaRPr sz="2400">
               <a:solidFill>
@@ -13646,24 +13682,35 @@
           </a:p>
           <a:p>
             <a:r>
-              <a:rPr sz="1300" b="0" i="0">
+              <a:rPr sz="1450" b="0" i="0">
                 <a:solidFill>
                   <a:srgbClr val="4B4877"/>
                 </a:solidFill>
-                <a:latin typeface="Calibri"/>
+                <a:latin typeface="Times New Roman"/>
               </a:rPr>
-              <a:t>The data already exists in every factory — trapped in mixed Bangla/English Excels, ERP exports and paper trim cards. Global traceability platforms are brand-side and enterprise-priced; nobody captures at the Bangladeshi factory floor.</a:t>
+              <a:t>ESPR in force 18 Jul 2024 · textiles in the first Working Plan (Apr 2025) · textile delegated act expected ~2027.</a:t>
             </a:r>
           </a:p>
           <a:p>
             <a:r>
-              <a:rPr sz="1300" b="0" i="0">
+              <a:rPr sz="1450" b="0" i="0">
                 <a:solidFill>
                   <a:srgbClr val="4B4877"/>
                 </a:solidFill>
-                <a:latin typeface="Calibri"/>
+                <a:latin typeface="Times New Roman"/>
               </a:rPr>
-              <a:t>Most affected: small &amp; mid-size exporters without compliance teams — and, through them, the ≈4 million garment workers (BGMEA; majority women) whose livelihoods ride on Europe, the industry’s biggest market.</a:t>
+              <a:t>Every factory already holds the proof — trapped in mixed Bangla/English Excels, ERP exports and paper trim cards. Global platforms are brand-side; nobody captures at the factory floor.</a:t>
+            </a:r>
+          </a:p>
+          <a:p>
+            <a:r>
+              <a:rPr sz="1450" b="0" i="0">
+                <a:solidFill>
+                  <a:srgbClr val="4B4877"/>
+                </a:solidFill>
+                <a:latin typeface="Times New Roman"/>
+              </a:rPr>
+              <a:t>Most affected: small &amp; mid-size exporters — and ≈ 4 million garment workers (BGMEA; majority women) whose market is Europe.</a:t>
             </a:r>
           </a:p>
         </p:txBody>
@@ -13684,8 +13731,8 @@
         </p:blipFill>
         <p:spPr>
           <a:xfrm>
-            <a:off x="1750000" y="3250000"/>
-            <a:ext cx="10600000" cy="2583311"/>
+            <a:off x="616353" y="3450000"/>
+            <a:ext cx="10600000" cy="2520857"/>
           </a:xfrm>
           <a:prstGeom prst="rect">
             <a:avLst/>
@@ -13845,7 +13892,7 @@
                 <a:solidFill>
                   <a:srgbClr val="142346"/>
                 </a:solidFill>
-                <a:latin typeface="Inter"/>
+                <a:latin typeface="Times New Roman"/>
                 <a:ea typeface="Inter"/>
                 <a:cs typeface="Inter"/>
                 <a:sym typeface="Inter"/>
@@ -13872,8 +13919,8 @@
         </p:nvSpPr>
         <p:spPr>
           <a:xfrm>
-            <a:off x="456353" y="1150000"/>
-            <a:ext cx="11085000" cy="2450000"/>
+            <a:off x="455197" y="1050000"/>
+            <a:ext cx="11281606" cy="2300000"/>
           </a:xfrm>
           <a:prstGeom prst="rect">
             <a:avLst/>
@@ -13899,13 +13946,13 @@
               <a:buNone/>
             </a:pPr>
             <a:r>
-              <a:rPr sz="1400" b="1" i="0">
+              <a:rPr sz="1650" b="1" i="0">
                 <a:solidFill>
                   <a:srgbClr val="1E1B4B"/>
                 </a:solidFill>
-                <a:latin typeface="Calibri"/>
+                <a:latin typeface="Times New Roman"/>
               </a:rPr>
-              <a:t>Porichoy turns a factory’s existing records into buyer-ready EU Digital Product Passports in four steps — all live today, offline-tolerant, Bangla + English:</a:t>
+              <a:t>Our live pilot app turns a factory’s existing records into buyer-ready EU Digital Product Passports in four steps:</a:t>
             </a:r>
             <a:endParaRPr b="1" sz="2000">
               <a:solidFill>
@@ -13919,57 +13966,57 @@
           </a:p>
           <a:p>
             <a:r>
-              <a:rPr sz="1250" b="0" i="0">
+              <a:rPr sz="1500" b="0" i="0">
                 <a:solidFill>
                   <a:srgbClr val="4B4877"/>
                 </a:solidFill>
-                <a:latin typeface="Calibri"/>
+                <a:latin typeface="Times New Roman"/>
               </a:rPr>
-              <a:t>1 · INGEST — drop the factory Excel/CSV; every sheet parsed on-device. Nothing leaves the factory (local-first).</a:t>
+              <a:t>1 · INGEST — drop the factory Excel/CSV; parsed on-device. Raw data never leaves the factory.</a:t>
             </a:r>
           </a:p>
           <a:p>
             <a:r>
-              <a:rPr sz="1250" b="0" i="0">
+              <a:rPr sz="1500" b="0" i="0">
                 <a:solidFill>
                   <a:srgbClr val="4B4877"/>
                 </a:solidFill>
-                <a:latin typeface="Calibri"/>
+                <a:latin typeface="Times New Roman"/>
               </a:rPr>
-              <a:t>2 · MAP — the engine reads chaotic Bangla/English headers with confidence scores; a trained steward confirms; the factory’s vocabulary is learned.</a:t>
+              <a:t>2 · MAP — Bangla/English headers auto-mapped with confidence scores; a trained steward confirms.</a:t>
             </a:r>
           </a:p>
           <a:p>
             <a:r>
-              <a:rPr sz="1250" b="0" i="0">
+              <a:rPr sz="1500" b="0" i="0">
                 <a:solidFill>
                   <a:srgbClr val="4B4877"/>
                 </a:solidFill>
-                <a:latin typeface="Calibri"/>
+                <a:latin typeface="Times New Roman"/>
               </a:rPr>
-              <a:t>3 · SCORE — DPP Readiness 0–100 per production order (weights = ESPR Art. 8 categories) with the exact gap list.</a:t>
+              <a:t>3 · SCORE — DPP Readiness 0–100 per order (ESPR Art. 8 weights) + the exact gap list.</a:t>
             </a:r>
           </a:p>
           <a:p>
             <a:r>
-              <a:rPr sz="1250" b="0" i="0">
+              <a:rPr sz="1500" b="0" i="0">
                 <a:solidFill>
                   <a:srgbClr val="4B4877"/>
                 </a:solidFill>
-                <a:latin typeface="Calibri"/>
+                <a:latin typeface="Times New Roman"/>
               </a:rPr>
-              <a:t>4 · PASSPORT — one click → a QR whose link embeds the passport; scanning opens the buyer view on any phone. No backend.</a:t>
+              <a:t>4 · PASSPORT — one click → QR; buyers scan and see the verifiable passport.</a:t>
             </a:r>
           </a:p>
           <a:p>
             <a:r>
-              <a:rPr sz="1200" b="1" i="0">
+              <a:rPr sz="1400" b="1" i="0">
                 <a:solidFill>
                   <a:srgbClr val="E11D74"/>
                 </a:solidFill>
-                <a:latin typeface="Calibri"/>
+                <a:latin typeface="Times New Roman"/>
               </a:rPr>
-              <a:t>19/19 automated engine tests · SHA-256 provenance chain · stewards fix gaps in-place and the score updates instantly.</a:t>
+              <a:t>19/19 automated engine tests · SHA-256 provenance chain · Bangla + English · offline-tolerant</a:t>
             </a:r>
           </a:p>
         </p:txBody>
@@ -13990,8 +14037,8 @@
         </p:blipFill>
         <p:spPr>
           <a:xfrm>
-            <a:off x="1700000" y="3720000"/>
-            <a:ext cx="3400000" cy="2125000"/>
+            <a:off x="1600000" y="3480000"/>
+            <a:ext cx="4560000" cy="2850000"/>
           </a:xfrm>
           <a:prstGeom prst="rect">
             <a:avLst/>
@@ -14014,32 +14061,8 @@
         </p:blipFill>
         <p:spPr>
           <a:xfrm>
-            <a:off x="5150000" y="3720000"/>
-            <a:ext cx="3400000" cy="2125000"/>
-          </a:xfrm>
-          <a:prstGeom prst="rect">
-            <a:avLst/>
-          </a:prstGeom>
-        </p:spPr>
-      </p:pic>
-      <p:pic>
-        <p:nvPicPr>
-          <p:cNvPr id="135" name="Picture 134" descr="porichoy_evidence.png"/>
-          <p:cNvPicPr>
-            <a:picLocks noChangeAspect="1"/>
-          </p:cNvPicPr>
-          <p:nvPr/>
-        </p:nvPicPr>
-        <p:blipFill>
-          <a:blip r:embed="rId8"/>
-          <a:stretch>
-            <a:fillRect/>
-          </a:stretch>
-        </p:blipFill>
-        <p:spPr>
-          <a:xfrm>
-            <a:off x="8600000" y="3720000"/>
-            <a:ext cx="3400000" cy="2125000"/>
+            <a:off x="6560000" y="3480000"/>
+            <a:ext cx="4560000" cy="2850000"/>
           </a:xfrm>
           <a:prstGeom prst="rect">
             <a:avLst/>
@@ -14048,14 +14071,14 @@
       </p:pic>
       <p:sp>
         <p:nvSpPr>
-          <p:cNvPr id="136" name="TextBox 135"/>
+          <p:cNvPr id="135" name="TextBox 134"/>
           <p:cNvSpPr txBox="1"/>
           <p:nvPr/>
         </p:nvSpPr>
         <p:spPr>
           <a:xfrm>
-            <a:off x="1700000" y="6050000"/>
-            <a:ext cx="10000000" cy="190000"/>
+            <a:off x="1600000" y="6400000"/>
+            <a:ext cx="10400000" cy="330000"/>
           </a:xfrm>
           <a:prstGeom prst="rect">
             <a:avLst/>
@@ -14063,19 +14086,19 @@
           <a:noFill/>
         </p:spPr>
         <p:txBody>
-          <a:bodyPr wrap="none">
+          <a:bodyPr wrap="square">
             <a:spAutoFit/>
           </a:bodyPr>
           <a:lstStyle/>
           <a:p>
             <a:r>
-              <a:rPr sz="1000" b="0" i="1">
+              <a:rPr sz="1150" b="0" i="1">
                 <a:solidFill>
                   <a:srgbClr val="4B4877"/>
                 </a:solidFill>
-                <a:latin typeface="Calibri"/>
+                <a:latin typeface="Times New Roman"/>
               </a:rPr>
-              <a:t>Live production app — screenshots fetched 2026-09-13 · rudra496.github.io/porichoy</a:t>
+              <a:t>Live pilot app (demo data shown) · evidence page with 16 Crossref-verified studies · grant roadmap: OCR for paper trim cards, ERP/API connectors, multi-factory cloud sync</a:t>
             </a:r>
           </a:p>
         </p:txBody>
@@ -14233,7 +14256,7 @@
                 <a:solidFill>
                   <a:srgbClr val="142346"/>
                 </a:solidFill>
-                <a:latin typeface="Inter"/>
+                <a:latin typeface="Times New Roman"/>
                 <a:ea typeface="Inter"/>
                 <a:cs typeface="Inter"/>
                 <a:sym typeface="Inter"/>
@@ -14260,8 +14283,8 @@
         </p:nvSpPr>
         <p:spPr>
           <a:xfrm>
-            <a:off x="456353" y="1150000"/>
-            <a:ext cx="11085000" cy="2200000"/>
+            <a:off x="455197" y="1100000"/>
+            <a:ext cx="11281606" cy="2250000"/>
           </a:xfrm>
           <a:prstGeom prst="rect">
             <a:avLst/>
@@ -14287,11 +14310,11 @@
               <a:buNone/>
             </a:pPr>
             <a:r>
-              <a:rPr sz="1400" b="1" i="0">
+              <a:rPr sz="1700" b="1" i="0">
                 <a:solidFill>
                   <a:srgbClr val="1E1B4B"/>
                 </a:solidFill>
-                <a:latin typeface="Calibri"/>
+                <a:latin typeface="Times New Roman"/>
               </a:rPr>
               <a:t>A dated compliance wall creates a forced-adoption market:</a:t>
             </a:r>
@@ -14299,35 +14322,35 @@
           </a:p>
           <a:p>
             <a:r>
-              <a:rPr sz="1300" b="0" i="0">
+              <a:rPr sz="1500" b="0" i="0">
                 <a:solidFill>
                   <a:srgbClr val="4B4877"/>
                 </a:solidFill>
-                <a:latin typeface="Calibri"/>
+                <a:latin typeface="Times New Roman"/>
               </a:rPr>
-              <a:t>≈ 4 million RMG workers (BGMEA) · world’s #2 ready-made garment exporter · Europe is the biggest market (NIC 3.0 call) · thousands of export factories in the BGMEA member base — every one shipping to the EU must be DPP-ready inside the 2027–30 window.</a:t>
+              <a:t>≈ 4 million RMG workers (BGMEA; majority women) · world’s #2 ready-made garment exporter · Europe is the biggest market · thousands of export factories must be DPP-ready inside the 2027–30 window.</a:t>
             </a:r>
           </a:p>
           <a:p>
             <a:r>
-              <a:rPr sz="1300" b="1" i="0">
+              <a:rPr sz="1500" b="1" i="0">
                 <a:solidFill>
                   <a:srgbClr val="1E1B4B"/>
                 </a:solidFill>
-                <a:latin typeface="Calibri"/>
+                <a:latin typeface="Times New Roman"/>
               </a:rPr>
-              <a:t>Illustrative revenue math on Porichoy’s own pricing (BDT 2,000–8,000/factory/month):</a:t>
+              <a:t>Revenue math on our own pricing (BDT 2,000–8,000 / factory / month):</a:t>
             </a:r>
           </a:p>
           <a:p>
             <a:r>
-              <a:rPr sz="1300" b="0" i="0">
+              <a:rPr sz="1500" b="0" i="0">
                 <a:solidFill>
                   <a:srgbClr val="4B4877"/>
                 </a:solidFill>
-                <a:latin typeface="Calibri"/>
+                <a:latin typeface="Times New Roman"/>
               </a:rPr>
-              <a:t>100 pilot-scale factories ≈ BDT 60 lakh/year · 1,000 factories ≈ BDT 6 crore/year — before brand-funded supplier-onboarding contracts, where buyers pay to bring their supplier base onto passports before the deadline.</a:t>
+              <a:t>100 factories ≈ BDT 60 lakh / year · 1,000 factories ≈ BDT 6 crore / year — before brand-funded onboarding contracts, where buyers pay to bring their suppliers onto passports before the deadline.</a:t>
             </a:r>
           </a:p>
         </p:txBody>
@@ -14340,8 +14363,8 @@
         </p:nvSpPr>
         <p:spPr>
           <a:xfrm>
-            <a:off x="456353" y="3550000"/>
-            <a:ext cx="2650000" cy="1050000"/>
+            <a:off x="455197" y="3600000"/>
+            <a:ext cx="2700000" cy="1250000"/>
           </a:xfrm>
           <a:prstGeom prst="roundRect">
             <a:avLst/>
@@ -14369,27 +14392,28 @@
           </a:fontRef>
         </p:style>
         <p:txBody>
-          <a:bodyPr rtlCol="0" anchor="ctr"/>
+          <a:bodyPr rtlCol="0" anchor="ctr" wrap="square"/>
           <a:lstStyle/>
           <a:p>
             <a:pPr algn="ctr"/>
             <a:r>
-              <a:rPr sz="1700" b="1">
+              <a:rPr sz="2000" b="1">
                 <a:solidFill>
-                  <a:srgbClr val="E11D74"/>
+                  <a:srgbClr val="F9A8D4"/>
                 </a:solidFill>
-                <a:latin typeface="Calibri"/>
+                <a:latin typeface="Times New Roman"/>
               </a:rPr>
-              <a:t>≈4 million</a:t>
+              <a:t>≈ 4 million</a:t>
             </a:r>
           </a:p>
           <a:p>
+            <a:pPr algn="ctr"/>
             <a:r>
-              <a:rPr sz="1000">
+              <a:rPr sz="1150">
                 <a:solidFill>
                   <a:srgbClr val="FFFFFF"/>
                 </a:solidFill>
-                <a:latin typeface="Calibri"/>
+                <a:latin typeface="Times New Roman"/>
               </a:rPr>
               <a:t>RMG workers, majority women (BGMEA)</a:t>
             </a:r>
@@ -14404,8 +14428,8 @@
         </p:nvSpPr>
         <p:spPr>
           <a:xfrm>
-            <a:off x="3306353" y="3550000"/>
-            <a:ext cx="2650000" cy="1050000"/>
+            <a:off x="3317066" y="3600000"/>
+            <a:ext cx="2700000" cy="1250000"/>
           </a:xfrm>
           <a:prstGeom prst="roundRect">
             <a:avLst/>
@@ -14433,27 +14457,28 @@
           </a:fontRef>
         </p:style>
         <p:txBody>
-          <a:bodyPr rtlCol="0" anchor="ctr"/>
+          <a:bodyPr rtlCol="0" anchor="ctr" wrap="square"/>
           <a:lstStyle/>
           <a:p>
             <a:pPr algn="ctr"/>
             <a:r>
-              <a:rPr sz="1700" b="1">
+              <a:rPr sz="2000" b="1">
                 <a:solidFill>
-                  <a:srgbClr val="E11D74"/>
+                  <a:srgbClr val="F9A8D4"/>
                 </a:solidFill>
-                <a:latin typeface="Calibri"/>
+                <a:latin typeface="Times New Roman"/>
               </a:rPr>
               <a:t>#2 exporter</a:t>
             </a:r>
           </a:p>
           <a:p>
+            <a:pPr algn="ctr"/>
             <a:r>
-              <a:rPr sz="1000">
+              <a:rPr sz="1150">
                 <a:solidFill>
                   <a:srgbClr val="FFFFFF"/>
                 </a:solidFill>
-                <a:latin typeface="Calibri"/>
+                <a:latin typeface="Times New Roman"/>
               </a:rPr>
               <a:t>world RMG — Europe the biggest market</a:t>
             </a:r>
@@ -14468,8 +14493,8 @@
         </p:nvSpPr>
         <p:spPr>
           <a:xfrm>
-            <a:off x="6156353" y="3550000"/>
-            <a:ext cx="2650000" cy="1050000"/>
+            <a:off x="6178935" y="3600000"/>
+            <a:ext cx="2700000" cy="1250000"/>
           </a:xfrm>
           <a:prstGeom prst="roundRect">
             <a:avLst/>
@@ -14497,27 +14522,28 @@
           </a:fontRef>
         </p:style>
         <p:txBody>
-          <a:bodyPr rtlCol="0" anchor="ctr"/>
+          <a:bodyPr rtlCol="0" anchor="ctr" wrap="square"/>
           <a:lstStyle/>
           <a:p>
             <a:pPr algn="ctr"/>
             <a:r>
-              <a:rPr sz="1700" b="1">
+              <a:rPr sz="2000" b="1">
                 <a:solidFill>
-                  <a:srgbClr val="E11D74"/>
+                  <a:srgbClr val="F9A8D4"/>
                 </a:solidFill>
-                <a:latin typeface="Calibri"/>
+                <a:latin typeface="Times New Roman"/>
               </a:rPr>
               <a:t>2027–30</a:t>
             </a:r>
           </a:p>
           <a:p>
+            <a:pPr algn="ctr"/>
             <a:r>
-              <a:rPr sz="1000">
+              <a:rPr sz="1150">
                 <a:solidFill>
                   <a:srgbClr val="FFFFFF"/>
                 </a:solidFill>
-                <a:latin typeface="Calibri"/>
+                <a:latin typeface="Times New Roman"/>
               </a:rPr>
               <a:t>EU DPP phase-in; customs auto-checks</a:t>
             </a:r>
@@ -14532,8 +14558,8 @@
         </p:nvSpPr>
         <p:spPr>
           <a:xfrm>
-            <a:off x="9006353" y="3550000"/>
-            <a:ext cx="2650000" cy="1050000"/>
+            <a:off x="9040804" y="3600000"/>
+            <a:ext cx="2700000" cy="1250000"/>
           </a:xfrm>
           <a:prstGeom prst="roundRect">
             <a:avLst/>
@@ -14561,27 +14587,28 @@
           </a:fontRef>
         </p:style>
         <p:txBody>
-          <a:bodyPr rtlCol="0" anchor="ctr"/>
+          <a:bodyPr rtlCol="0" anchor="ctr" wrap="square"/>
           <a:lstStyle/>
           <a:p>
             <a:pPr algn="ctr"/>
             <a:r>
-              <a:rPr sz="1700" b="1">
+              <a:rPr sz="2000" b="1">
                 <a:solidFill>
-                  <a:srgbClr val="E11D74"/>
+                  <a:srgbClr val="F9A8D4"/>
                 </a:solidFill>
-                <a:latin typeface="Calibri"/>
+                <a:latin typeface="Times New Roman"/>
               </a:rPr>
-              <a:t>10→100+</a:t>
+              <a:t>10 → 100+</a:t>
             </a:r>
           </a:p>
           <a:p>
+            <a:pPr algn="ctr"/>
             <a:r>
-              <a:rPr sz="1000">
+              <a:rPr sz="1150">
                 <a:solidFill>
                   <a:srgbClr val="FFFFFF"/>
                 </a:solidFill>
-                <a:latin typeface="Calibri"/>
+                <a:latin typeface="Times New Roman"/>
               </a:rPr>
               <a:t>factories: year-1 pilot → year-3 scale</a:t>
             </a:r>
@@ -14596,8 +14623,8 @@
         </p:nvSpPr>
         <p:spPr>
           <a:xfrm>
-            <a:off x="456353" y="4900000"/>
-            <a:ext cx="10100000" cy="950000"/>
+            <a:off x="455197" y="5150000"/>
+            <a:ext cx="10100000" cy="900000"/>
           </a:xfrm>
           <a:prstGeom prst="rect">
             <a:avLst/>
@@ -14605,19 +14632,19 @@
           <a:noFill/>
         </p:spPr>
         <p:txBody>
-          <a:bodyPr wrap="none">
+          <a:bodyPr wrap="square">
             <a:spAutoFit/>
           </a:bodyPr>
           <a:lstStyle/>
           <a:p>
             <a:r>
-              <a:rPr sz="1200" b="0" i="0">
+              <a:rPr sz="1400" b="0" i="0">
                 <a:solidFill>
                   <a:srgbClr val="4B4877"/>
                 </a:solidFill>
-                <a:latin typeface="Calibri"/>
+                <a:latin typeface="Times New Roman"/>
               </a:rPr>
-              <a:t>Timing is the wedge: buyers already ask, budgets activate before the deadline, and no Bangladesh-built tool serves the factory floor today — the verified competitors are brand-side only.</a:t>
+              <a:t>Timing is the wedge: buyers already ask, budgets activate before the deadline — and no Bangladesh-built tool serves the factory floor today. Verified competitors are brand-side only.</a:t>
             </a:r>
           </a:p>
         </p:txBody>
@@ -14775,7 +14802,7 @@
                 <a:solidFill>
                   <a:srgbClr val="142346"/>
                 </a:solidFill>
-                <a:latin typeface="Inter"/>
+                <a:latin typeface="Times New Roman"/>
                 <a:ea typeface="Inter"/>
                 <a:cs typeface="Inter"/>
                 <a:sym typeface="Inter"/>
@@ -14802,8 +14829,8 @@
         </p:nvSpPr>
         <p:spPr>
           <a:xfrm>
-            <a:off x="456353" y="1150000"/>
-            <a:ext cx="11085000" cy="2300000"/>
+            <a:off x="455197" y="1100000"/>
+            <a:ext cx="11281606" cy="2350000"/>
           </a:xfrm>
           <a:prstGeom prst="rect">
             <a:avLst/>
@@ -14829,11 +14856,11 @@
               <a:buNone/>
             </a:pPr>
             <a:r>
-              <a:rPr sz="1400" b="1" i="0">
+              <a:rPr sz="1700" b="1" i="0">
                 <a:solidFill>
                   <a:srgbClr val="1E1B4B"/>
                 </a:solidFill>
-                <a:latin typeface="Calibri"/>
+                <a:latin typeface="Times New Roman"/>
               </a:rPr>
               <a:t>Three simple revenue lines:</a:t>
             </a:r>
@@ -14849,46 +14876,46 @@
           </a:p>
           <a:p>
             <a:r>
-              <a:rPr sz="1250" b="0" i="0">
+              <a:rPr sz="1500" b="0" i="0">
                 <a:solidFill>
                   <a:srgbClr val="4B4877"/>
                 </a:solidFill>
-                <a:latin typeface="Calibri"/>
+                <a:latin typeface="Times New Roman"/>
               </a:rPr>
-              <a:t>1. Factory subscriptions — BDT 2,000–8,000/month by size (SME-priced, ~10× below enterprise platforms).</a:t>
+              <a:t>1. Factory subscriptions — BDT 2,000–8,000 / month by size (SME-priced, ~10× below enterprise platforms).</a:t>
             </a:r>
           </a:p>
           <a:p>
             <a:r>
-              <a:rPr sz="1250" b="0" i="0">
+              <a:rPr sz="1500" b="0" i="0">
                 <a:solidFill>
                   <a:srgbClr val="4B4877"/>
                 </a:solidFill>
-                <a:latin typeface="Calibri"/>
+                <a:latin typeface="Times New Roman"/>
               </a:rPr>
               <a:t>2. Onboarding &amp; data-rescue — one-time fee: steward training + first ingest + mapping historic files.</a:t>
             </a:r>
           </a:p>
           <a:p>
             <a:r>
-              <a:rPr sz="1250" b="0" i="0">
+              <a:rPr sz="1500" b="0" i="0">
                 <a:solidFill>
                   <a:srgbClr val="4B4877"/>
                 </a:solidFill>
-                <a:latin typeface="Calibri"/>
+                <a:latin typeface="Times New Roman"/>
               </a:rPr>
               <a:t>3. Brand-funded supplier onboarding — buyers pay to make their supplier base passport-ready before 2027–30.</a:t>
             </a:r>
           </a:p>
           <a:p>
             <a:r>
-              <a:rPr sz="1250" b="1" i="0">
+              <a:rPr sz="1400" b="1" i="0">
                 <a:solidFill>
                   <a:srgbClr val="E11D74"/>
                 </a:solidFill>
-                <a:latin typeface="Calibri"/>
+                <a:latin typeface="Times New Roman"/>
               </a:rPr>
-              <a:t>Unit economics: onboarding ≈ 2 person-days/factory · software gross margin &gt;80% · replication is a template, not a project.</a:t>
+              <a:t>Unit economics: onboarding ≈ 2 person-days / factory · software gross margin &gt; 80% · replication is a template, not a project.</a:t>
             </a:r>
           </a:p>
         </p:txBody>
@@ -14909,8 +14936,8 @@
         </p:blipFill>
         <p:spPr>
           <a:xfrm>
-            <a:off x="7150000" y="2900000"/>
-            <a:ext cx="4093548" cy="2700000"/>
+            <a:off x="7000000" y="3000000"/>
+            <a:ext cx="3952129" cy="2850000"/>
           </a:xfrm>
           <a:prstGeom prst="rect">
             <a:avLst/>
@@ -14925,8 +14952,8 @@
         </p:nvSpPr>
         <p:spPr>
           <a:xfrm>
-            <a:off x="456353" y="3000000"/>
-            <a:ext cx="5600000" cy="1400000"/>
+            <a:off x="455197" y="3650000"/>
+            <a:ext cx="6200000" cy="1500000"/>
           </a:xfrm>
           <a:prstGeom prst="rect">
             <a:avLst/>
@@ -14934,28 +14961,28 @@
           <a:noFill/>
         </p:spPr>
         <p:txBody>
-          <a:bodyPr wrap="none">
+          <a:bodyPr wrap="square">
             <a:spAutoFit/>
           </a:bodyPr>
           <a:lstStyle/>
           <a:p>
             <a:r>
-              <a:rPr sz="1250" b="1" i="0">
+              <a:rPr sz="1500" b="1" i="0">
                 <a:solidFill>
                   <a:srgbClr val="1E1B4B"/>
                 </a:solidFill>
-                <a:latin typeface="Calibri"/>
+                <a:latin typeface="Times New Roman"/>
               </a:rPr>
               <a:t>Pollination grant (BDT 650,000) funds the 10-factory pilot:</a:t>
             </a:r>
           </a:p>
           <a:p>
             <a:r>
-              <a:rPr sz="1200" b="0" i="0">
+              <a:rPr sz="1400" b="0" i="0">
                 <a:solidFill>
                   <a:srgbClr val="4B4877"/>
                 </a:solidFill>
-                <a:latin typeface="Calibri"/>
+                <a:latin typeface="Times New Roman"/>
               </a:rPr>
               <a:t>BDT 220k pilot + steward training · 180k OCR for paper trim cards · 150k mapping corpus (Bangla + ERP formats) · 100k legal &amp; compliance.</a:t>
             </a:r>
@@ -15076,8 +15103,8 @@
         </p:nvSpPr>
         <p:spPr>
           <a:xfrm>
-            <a:off x="456353" y="1150000"/>
-            <a:ext cx="11085094" cy="2200000"/>
+            <a:off x="455197" y="1100000"/>
+            <a:ext cx="11281606" cy="2250000"/>
           </a:xfrm>
           <a:prstGeom prst="rect">
             <a:avLst/>
@@ -15103,13 +15130,13 @@
               <a:buNone/>
             </a:pPr>
             <a:r>
-              <a:rPr sz="1250" b="0" i="0">
+              <a:rPr sz="1500" b="0" i="0">
                 <a:solidFill>
                   <a:srgbClr val="4B4877"/>
                 </a:solidFill>
-                <a:latin typeface="Calibri"/>
+                <a:latin typeface="Times New Roman"/>
               </a:rPr>
-              <a:t>Competitiveness: EU-order eligibility is protected (customs auto-checks), compliance prep per PO drops from days of file-hunting to under an hour, and readiness scores make factories the buyer-preferred choice.</a:t>
+              <a:t>Competitiveness: customs auto-checks make passport data order-critical — and compliance prep drops from days of file-hunting to under an hour per order.</a:t>
             </a:r>
             <a:endParaRPr b="1" sz="2000">
               <a:solidFill>
@@ -15123,24 +15150,24 @@
           </a:p>
           <a:p>
             <a:r>
-              <a:rPr sz="1250" b="0" i="0">
+              <a:rPr sz="1500" b="0" i="0">
                 <a:solidFill>
                   <a:srgbClr val="4B4877"/>
                 </a:solidFill>
-                <a:latin typeface="Calibri"/>
+                <a:latin typeface="Times New Roman"/>
               </a:rPr>
-              <a:t>Women: two women operators per factory are trained &amp; certified as DPP Data Stewards — formal, higher-skilled roles (20 in year 1 → 200 by year 3, targets) — and keeping factories order-eligible protects a majority-women workforce (≈4M workers, BGMEA).</a:t>
+              <a:t>Women: two women operators per factory trained &amp; certified as DPP Data Stewards — formal, higher-skilled roles (20 in year 1 → 200 by year 3, targets). Order-eligibility protects a majority-women workforce (≈ 4 million, BGMEA).</a:t>
             </a:r>
           </a:p>
           <a:p>
             <a:r>
-              <a:rPr sz="1250" b="0" i="0">
+              <a:rPr sz="1500" b="0" i="0">
                 <a:solidFill>
                   <a:srgbClr val="4B4877"/>
                 </a:solidFill>
-                <a:latin typeface="Calibri"/>
+                <a:latin typeface="Times New Roman"/>
               </a:rPr>
-              <a:t>Circularity: DPP fields make recycled content, certificates and end-of-life routes verifiable — turning circularity claims into machine-checkable data that flows to buyers and recyclers.</a:t>
+              <a:t>Circularity: recycled content, certificates and end-of-life routes become machine-checkable passport fields — circularity claims turn into verifiable data.</a:t>
             </a:r>
           </a:p>
         </p:txBody>
@@ -15192,7 +15219,7 @@
                 <a:solidFill>
                   <a:srgbClr val="142346"/>
                 </a:solidFill>
-                <a:latin typeface="Inter"/>
+                <a:latin typeface="Times New Roman"/>
                 <a:ea typeface="Inter"/>
                 <a:cs typeface="Inter"/>
                 <a:sym typeface="Inter"/>
@@ -15227,8 +15254,8 @@
         </p:blipFill>
         <p:spPr>
           <a:xfrm>
-            <a:off x="1700000" y="3450000"/>
-            <a:ext cx="4400000" cy="2152488"/>
+            <a:off x="7100000" y="3300000"/>
+            <a:ext cx="4700000" cy="2294731"/>
           </a:xfrm>
           <a:prstGeom prst="rect">
             <a:avLst/>
@@ -15251,8 +15278,8 @@
         </p:blipFill>
         <p:spPr>
           <a:xfrm>
-            <a:off x="6350000" y="3450000"/>
-            <a:ext cx="3200000" cy="2400000"/>
+            <a:off x="1700000" y="3300000"/>
+            <a:ext cx="3466666" cy="2600000"/>
           </a:xfrm>
           <a:prstGeom prst="rect">
             <a:avLst/>
@@ -15267,8 +15294,8 @@
         </p:nvSpPr>
         <p:spPr>
           <a:xfrm>
-            <a:off x="1700000" y="6150000"/>
-            <a:ext cx="10000000" cy="190000"/>
+            <a:off x="1700000" y="6350000"/>
+            <a:ext cx="10000000" cy="300000"/>
           </a:xfrm>
           <a:prstGeom prst="rect">
             <a:avLst/>
@@ -15276,19 +15303,19 @@
           <a:noFill/>
         </p:spPr>
         <p:txBody>
-          <a:bodyPr wrap="none">
+          <a:bodyPr wrap="square">
             <a:spAutoFit/>
           </a:bodyPr>
           <a:lstStyle/>
           <a:p>
             <a:r>
-              <a:rPr sz="1000" b="0" i="1">
+              <a:rPr sz="1150" b="0" i="1">
                 <a:solidFill>
                   <a:srgbClr val="4B4877"/>
                 </a:solidFill>
-                <a:latin typeface="Calibri"/>
+                <a:latin typeface="Times New Roman"/>
               </a:rPr>
-              <a:t>Left: women-steward ramp (roadmap targets). Right: RMG factory floor — photo CC BY 2.0, Wikimedia Commons.</a:t>
+              <a:t>Women-steward ramp: roadmap targets. Photo: RMG factory floor — CC BY 2.0, Wikimedia Commons.</a:t>
             </a:r>
           </a:p>
         </p:txBody>
@@ -15446,7 +15473,7 @@
                 <a:solidFill>
                   <a:srgbClr val="142346"/>
                 </a:solidFill>
-                <a:latin typeface="Inter"/>
+                <a:latin typeface="Times New Roman"/>
                 <a:ea typeface="Inter"/>
                 <a:cs typeface="Inter"/>
                 <a:sym typeface="Inter"/>
@@ -15474,7 +15501,7 @@
         <p:spPr>
           <a:xfrm>
             <a:off x="1950000" y="1000000"/>
-            <a:ext cx="10100000" cy="1500000"/>
+            <a:ext cx="10100000" cy="1550000"/>
           </a:xfrm>
           <a:prstGeom prst="rect">
             <a:avLst/>
@@ -15500,11 +15527,11 @@
               <a:buNone/>
             </a:pPr>
             <a:r>
-              <a:rPr sz="1250" b="1" i="0">
+              <a:rPr sz="1400" b="1" i="0">
                 <a:solidFill>
                   <a:srgbClr val="1E1B4B"/>
                 </a:solidFill>
-                <a:latin typeface="Calibri"/>
+                <a:latin typeface="Times New Roman"/>
               </a:rPr>
               <a:t>Rudra Sarker — Founder &amp; full-time product engineer. Final-year B.Sc. Industrial &amp; Production Engineering, SUST. Builds every part of Porichoy: the EU-aligned DPP schema, the Bangla/English mapping engine, readiness scoring and the provenance chain.</a:t>
             </a:r>
@@ -15512,24 +15539,24 @@
           </a:p>
           <a:p>
             <a:r>
-              <a:rPr sz="1150" b="0" i="0">
+              <a:rPr sz="1300" b="0" i="0">
                 <a:solidFill>
                   <a:srgbClr val="4B4877"/>
                 </a:solidFill>
-                <a:latin typeface="Calibri"/>
+                <a:latin typeface="Times New Roman"/>
               </a:rPr>
-              <a:t>Awards &amp; achievements (verified): Q1 journal publication — Journal of Ethnopharmacology (Elsevier, 2026), 3rd author · Z.AI Global Ambassador (since Nov 2025) · IEF Bangladesh Ambassador (since Apr 2026) · Secretary, RoboSUST (2025–26) · GaoTek industrial internship (2024–25).</a:t>
+              <a:t>Verified awards: Q1 journal publication — Journal of Ethnopharmacology (Elsevier, 2026), 3rd author · Z.AI Global Ambassador · IEF Bangladesh Ambassador · Secretary, RoboSUST · GaoTek industrial internship.</a:t>
             </a:r>
           </a:p>
           <a:p>
             <a:r>
-              <a:rPr sz="1150" b="0" i="0">
+              <a:rPr sz="1300" b="0" i="0">
                 <a:solidFill>
                   <a:srgbClr val="4B4877"/>
                 </a:solidFill>
-                <a:latin typeface="Calibri"/>
+                <a:latin typeface="Times New Roman"/>
               </a:rPr>
-              <a:t>Two IPE backgrounds ground us in how factories actually run; systems engineering makes the software ship. Women lead our steward program by design — the same people the product trains and employs. No big-name advisers: 19/19 passing tests, public code and a live product speak instead.</a:t>
+              <a:t>Two IPE backgrounds ground us in factory reality; systems engineering makes the software ship. Women lead our steward program by design. No big-name advisers — a live product, public code and 19/19 passing tests speak instead.</a:t>
             </a:r>
           </a:p>
         </p:txBody>
@@ -15566,8 +15593,8 @@
         </p:nvSpPr>
         <p:spPr>
           <a:xfrm>
-            <a:off x="456353" y="2550000"/>
-            <a:ext cx="2707000" cy="1650000"/>
+            <a:off x="456353" y="2750000"/>
+            <a:ext cx="2707000" cy="1900000"/>
           </a:xfrm>
           <a:prstGeom prst="roundRect">
             <a:avLst/>
@@ -15600,44 +15627,44 @@
           <a:p>
             <a:pPr algn="ctr"/>
             <a:r>
-              <a:rPr sz="1200" b="1">
+              <a:rPr sz="1400" b="1">
                 <a:solidFill>
                   <a:srgbClr val="FFFFFF"/>
                 </a:solidFill>
-                <a:latin typeface="Calibri"/>
+                <a:latin typeface="Times New Roman"/>
               </a:rPr>
               <a:t>Lutfay Homaira Islam</a:t>
             </a:r>
           </a:p>
           <a:p>
             <a:r>
-              <a:rPr sz="900">
+              <a:rPr sz="1000">
                 <a:solidFill>
                   <a:srgbClr val="C7D2FE"/>
                 </a:solidFill>
-                <a:latin typeface="Calibri"/>
+                <a:latin typeface="Times New Roman"/>
               </a:rPr>
               <a:t>SUST · IPE</a:t>
             </a:r>
           </a:p>
           <a:p>
             <a:r>
-              <a:rPr sz="1000" b="1">
+              <a:rPr sz="1150" b="1">
                 <a:solidFill>
                   <a:srgbClr val="F9A8D4"/>
                 </a:solidFill>
-                <a:latin typeface="Calibri"/>
+                <a:latin typeface="Times New Roman"/>
               </a:rPr>
               <a:t>Factory Operations &amp; Pilot Lead</a:t>
             </a:r>
           </a:p>
           <a:p>
             <a:r>
-              <a:rPr sz="900">
+              <a:rPr sz="1050">
                 <a:solidFill>
                   <a:srgbClr val="E0E7FF"/>
                 </a:solidFill>
-                <a:latin typeface="Calibri"/>
+                <a:latin typeface="Times New Roman"/>
               </a:rPr>
               <a:t>Process mapping, factory data collection, readiness audits across the pilot factories</a:t>
             </a:r>
@@ -15652,8 +15679,8 @@
         </p:nvSpPr>
         <p:spPr>
           <a:xfrm>
-            <a:off x="3313353" y="2550000"/>
-            <a:ext cx="2707000" cy="1650000"/>
+            <a:off x="3313353" y="2750000"/>
+            <a:ext cx="2707000" cy="1900000"/>
           </a:xfrm>
           <a:prstGeom prst="roundRect">
             <a:avLst/>
@@ -15686,44 +15713,44 @@
           <a:p>
             <a:pPr algn="ctr"/>
             <a:r>
-              <a:rPr sz="1200" b="1">
+              <a:rPr sz="1400" b="1">
                 <a:solidFill>
                   <a:srgbClr val="FFFFFF"/>
                 </a:solidFill>
-                <a:latin typeface="Calibri"/>
+                <a:latin typeface="Times New Roman"/>
               </a:rPr>
               <a:t>Priom Sarker</a:t>
             </a:r>
           </a:p>
           <a:p>
             <a:r>
-              <a:rPr sz="900">
+              <a:rPr sz="1000">
                 <a:solidFill>
                   <a:srgbClr val="C7D2FE"/>
                 </a:solidFill>
-                <a:latin typeface="Calibri"/>
+                <a:latin typeface="Times New Roman"/>
               </a:rPr>
               <a:t>BUET · Naval Architecture &amp; Marine Engineering</a:t>
             </a:r>
           </a:p>
           <a:p>
             <a:r>
-              <a:rPr sz="1000" b="1">
+              <a:rPr sz="1150" b="1">
                 <a:solidFill>
                   <a:srgbClr val="F9A8D4"/>
                 </a:solidFill>
-                <a:latin typeface="Calibri"/>
+                <a:latin typeface="Times New Roman"/>
               </a:rPr>
               <a:t>Systems &amp; Technology Lead</a:t>
             </a:r>
           </a:p>
           <a:p>
             <a:r>
-              <a:rPr sz="900">
+              <a:rPr sz="1050">
                 <a:solidFill>
                   <a:srgbClr val="E0E7FF"/>
                 </a:solidFill>
-                <a:latin typeface="Calibri"/>
+                <a:latin typeface="Times New Roman"/>
               </a:rPr>
               <a:t>Systems architecture, ERP/API integrations, technical review of the ingestion pipeline</a:t>
             </a:r>
@@ -15738,8 +15765,8 @@
         </p:nvSpPr>
         <p:spPr>
           <a:xfrm>
-            <a:off x="6170353" y="2550000"/>
-            <a:ext cx="2707000" cy="1650000"/>
+            <a:off x="6170353" y="2750000"/>
+            <a:ext cx="2707000" cy="1900000"/>
           </a:xfrm>
           <a:prstGeom prst="roundRect">
             <a:avLst/>
@@ -15772,44 +15799,44 @@
           <a:p>
             <a:pPr algn="ctr"/>
             <a:r>
-              <a:rPr sz="1200" b="1">
+              <a:rPr sz="1400" b="1">
                 <a:solidFill>
                   <a:srgbClr val="FFFFFF"/>
                 </a:solidFill>
-                <a:latin typeface="Calibri"/>
+                <a:latin typeface="Times New Roman"/>
               </a:rPr>
               <a:t>Shuvo Kundu</a:t>
             </a:r>
           </a:p>
           <a:p>
             <a:r>
-              <a:rPr sz="900">
+              <a:rPr sz="1000">
                 <a:solidFill>
                   <a:srgbClr val="C7D2FE"/>
                 </a:solidFill>
-                <a:latin typeface="Calibri"/>
+                <a:latin typeface="Times New Roman"/>
               </a:rPr>
               <a:t>University of Asia Pacific · EEE</a:t>
             </a:r>
           </a:p>
           <a:p>
             <a:r>
-              <a:rPr sz="1000" b="1">
+              <a:rPr sz="1150" b="1">
                 <a:solidFill>
                   <a:srgbClr val="F9A8D4"/>
                 </a:solidFill>
-                <a:latin typeface="Calibri"/>
+                <a:latin typeface="Times New Roman"/>
               </a:rPr>
               <a:t>Data &amp; Research Lead</a:t>
             </a:r>
           </a:p>
           <a:p>
             <a:r>
-              <a:rPr sz="900">
+              <a:rPr sz="1050">
                 <a:solidFill>
                   <a:srgbClr val="E0E7FF"/>
                 </a:solidFill>
-                <a:latin typeface="Calibri"/>
+                <a:latin typeface="Times New Roman"/>
               </a:rPr>
               <a:t>Dataset curation, Bangla mapping-corpus growth, literature &amp; research support</a:t>
             </a:r>
@@ -15824,8 +15851,8 @@
         </p:nvSpPr>
         <p:spPr>
           <a:xfrm>
-            <a:off x="9027353" y="2550000"/>
-            <a:ext cx="2707000" cy="1650000"/>
+            <a:off x="9027353" y="2750000"/>
+            <a:ext cx="2707000" cy="1900000"/>
           </a:xfrm>
           <a:prstGeom prst="roundRect">
             <a:avLst/>
@@ -15858,44 +15885,44 @@
           <a:p>
             <a:pPr algn="ctr"/>
             <a:r>
-              <a:rPr sz="1200" b="1">
+              <a:rPr sz="1400" b="1">
                 <a:solidFill>
                   <a:srgbClr val="FFFFFF"/>
                 </a:solidFill>
-                <a:latin typeface="Calibri"/>
+                <a:latin typeface="Times New Roman"/>
               </a:rPr>
               <a:t>Samia Hossain</a:t>
             </a:r>
           </a:p>
           <a:p>
             <a:r>
-              <a:rPr sz="900">
+              <a:rPr sz="1000">
                 <a:solidFill>
                   <a:srgbClr val="C7D2FE"/>
                 </a:solidFill>
-                <a:latin typeface="Calibri"/>
+                <a:latin typeface="Times New Roman"/>
               </a:rPr>
               <a:t>Anwar Khan Modern University · CSE</a:t>
             </a:r>
           </a:p>
           <a:p>
             <a:r>
-              <a:rPr sz="1000" b="1">
+              <a:rPr sz="1150" b="1">
                 <a:solidFill>
                   <a:srgbClr val="F9A8D4"/>
                 </a:solidFill>
-                <a:latin typeface="Calibri"/>
+                <a:latin typeface="Times New Roman"/>
               </a:rPr>
               <a:t>Steward Training &amp; Outreach Lead</a:t>
             </a:r>
           </a:p>
           <a:p>
             <a:r>
-              <a:rPr sz="900">
+              <a:rPr sz="1050">
                 <a:solidFill>
                   <a:srgbClr val="E0E7FF"/>
                 </a:solidFill>
-                <a:latin typeface="Calibri"/>
+                <a:latin typeface="Times New Roman"/>
               </a:rPr>
               <a:t>Runs the women DPP Data Steward training program and factory outreach</a:t>
             </a:r>
@@ -15910,7 +15937,7 @@
         </p:nvSpPr>
         <p:spPr>
           <a:xfrm>
-            <a:off x="1700000" y="4600000"/>
+            <a:off x="1700000" y="5000000"/>
             <a:ext cx="10035000" cy="800000"/>
           </a:xfrm>
           <a:prstGeom prst="roundRect">
@@ -15944,22 +15971,23 @@
           <a:p>
             <a:pPr algn="ctr"/>
             <a:r>
-              <a:rPr sz="1300" b="1">
+              <a:rPr sz="1400" b="1">
                 <a:solidFill>
                   <a:srgbClr val="FFFFFF"/>
                 </a:solidFill>
-                <a:latin typeface="Calibri"/>
+                <a:latin typeface="Times New Roman"/>
               </a:rPr>
               <a:t>Live: rudra496.github.io/porichoy  ·  code: github.com/rudra496/porichoy  ·  19/19 engine tests  ·  launched Aug 2026</a:t>
             </a:r>
           </a:p>
           <a:p>
+            <a:pPr algn="ctr"/>
             <a:r>
-              <a:rPr sz="1100" i="1">
+              <a:rPr sz="1150" i="1">
                 <a:solidFill>
                   <a:srgbClr val="F9A8D4"/>
                 </a:solidFill>
-                <a:latin typeface="Calibri"/>
+                <a:latin typeface="Times New Roman"/>
               </a:rPr>
               <a:t>Everything we claim is checkable — that is the product’s whole point.</a:t>
             </a:r>
@@ -16178,7 +16206,7 @@
                 <a:solidFill>
                   <a:srgbClr val="142346"/>
                 </a:solidFill>
-                <a:latin typeface="Inter"/>
+                <a:latin typeface="Times New Roman"/>
                 <a:ea typeface="Inter"/>
                 <a:cs typeface="Inter"/>
                 <a:sym typeface="Inter"/>
@@ -16232,11 +16260,11 @@
               <a:buNone/>
             </a:pPr>
             <a:r>
-              <a:rPr sz="1600" b="1" i="0">
+              <a:rPr sz="1700" b="1" i="0">
                 <a:solidFill>
                   <a:srgbClr val="1E1B4B"/>
                 </a:solidFill>
-                <a:latin typeface="Calibri"/>
+                <a:latin typeface="Times New Roman"/>
               </a:rPr>
               <a:t>Name:  Rudra Sarker — Founder, Porichoy</a:t>
             </a:r>
@@ -16252,33 +16280,33 @@
           </a:p>
           <a:p>
             <a:r>
-              <a:rPr sz="1400" b="0" i="0">
+              <a:rPr sz="1500" b="0" i="0">
                 <a:solidFill>
                   <a:srgbClr val="4B4877"/>
                 </a:solidFill>
-                <a:latin typeface="Calibri"/>
+                <a:latin typeface="Times New Roman"/>
               </a:rPr>
               <a:t>Phone:  +8801988223165</a:t>
             </a:r>
           </a:p>
           <a:p>
             <a:r>
-              <a:rPr sz="1400" b="0" i="0">
+              <a:rPr sz="1500" b="0" i="0">
                 <a:solidFill>
                   <a:srgbClr val="4B4877"/>
                 </a:solidFill>
-                <a:latin typeface="Calibri"/>
+                <a:latin typeface="Times New Roman"/>
               </a:rPr>
               <a:t>Email:  rudrasarker125@gmail.com</a:t>
             </a:r>
           </a:p>
           <a:p>
             <a:r>
-              <a:rPr sz="1400" b="1" i="0">
+              <a:rPr sz="1500" b="1" i="0">
                 <a:solidFill>
                   <a:srgbClr val="4F46E5"/>
                 </a:solidFill>
-                <a:latin typeface="Calibri"/>
+                <a:latin typeface="Times New Roman"/>
               </a:rPr>
               <a:t>Live product:  rudra496.github.io/porichoy  ·  Code:  github.com/rudra496/porichoy</a:t>
             </a:r>

</xml_diff>